<commit_message>
Simplification of the data set to usefull data Column renaming
</commit_message>
<xml_diff>
--- a/notes/Analyses_OakPine_2026.pptx
+++ b/notes/Analyses_OakPine_2026.pptx
@@ -279,7 +279,7 @@
           <a:p>
             <a:fld id="{21B36A12-6976-4B31-BD04-D4227ACD3F51}" type="datetimeFigureOut">
               <a:rPr lang="fr-FR" smtClean="0"/>
-              <a:t>24/03/2026</a:t>
+              <a:t>06/05/2026</a:t>
             </a:fld>
             <a:endParaRPr lang="fr-FR"/>
           </a:p>
@@ -477,7 +477,7 @@
           <a:p>
             <a:fld id="{21B36A12-6976-4B31-BD04-D4227ACD3F51}" type="datetimeFigureOut">
               <a:rPr lang="fr-FR" smtClean="0"/>
-              <a:t>24/03/2026</a:t>
+              <a:t>06/05/2026</a:t>
             </a:fld>
             <a:endParaRPr lang="fr-FR"/>
           </a:p>
@@ -685,7 +685,7 @@
           <a:p>
             <a:fld id="{21B36A12-6976-4B31-BD04-D4227ACD3F51}" type="datetimeFigureOut">
               <a:rPr lang="fr-FR" smtClean="0"/>
-              <a:t>24/03/2026</a:t>
+              <a:t>06/05/2026</a:t>
             </a:fld>
             <a:endParaRPr lang="fr-FR"/>
           </a:p>
@@ -883,7 +883,7 @@
           <a:p>
             <a:fld id="{21B36A12-6976-4B31-BD04-D4227ACD3F51}" type="datetimeFigureOut">
               <a:rPr lang="fr-FR" smtClean="0"/>
-              <a:t>24/03/2026</a:t>
+              <a:t>06/05/2026</a:t>
             </a:fld>
             <a:endParaRPr lang="fr-FR"/>
           </a:p>
@@ -1158,7 +1158,7 @@
           <a:p>
             <a:fld id="{21B36A12-6976-4B31-BD04-D4227ACD3F51}" type="datetimeFigureOut">
               <a:rPr lang="fr-FR" smtClean="0"/>
-              <a:t>24/03/2026</a:t>
+              <a:t>06/05/2026</a:t>
             </a:fld>
             <a:endParaRPr lang="fr-FR"/>
           </a:p>
@@ -1423,7 +1423,7 @@
           <a:p>
             <a:fld id="{21B36A12-6976-4B31-BD04-D4227ACD3F51}" type="datetimeFigureOut">
               <a:rPr lang="fr-FR" smtClean="0"/>
-              <a:t>24/03/2026</a:t>
+              <a:t>06/05/2026</a:t>
             </a:fld>
             <a:endParaRPr lang="fr-FR"/>
           </a:p>
@@ -1835,7 +1835,7 @@
           <a:p>
             <a:fld id="{21B36A12-6976-4B31-BD04-D4227ACD3F51}" type="datetimeFigureOut">
               <a:rPr lang="fr-FR" smtClean="0"/>
-              <a:t>24/03/2026</a:t>
+              <a:t>06/05/2026</a:t>
             </a:fld>
             <a:endParaRPr lang="fr-FR"/>
           </a:p>
@@ -1976,7 +1976,7 @@
           <a:p>
             <a:fld id="{21B36A12-6976-4B31-BD04-D4227ACD3F51}" type="datetimeFigureOut">
               <a:rPr lang="fr-FR" smtClean="0"/>
-              <a:t>24/03/2026</a:t>
+              <a:t>06/05/2026</a:t>
             </a:fld>
             <a:endParaRPr lang="fr-FR"/>
           </a:p>
@@ -2089,7 +2089,7 @@
           <a:p>
             <a:fld id="{21B36A12-6976-4B31-BD04-D4227ACD3F51}" type="datetimeFigureOut">
               <a:rPr lang="fr-FR" smtClean="0"/>
-              <a:t>24/03/2026</a:t>
+              <a:t>06/05/2026</a:t>
             </a:fld>
             <a:endParaRPr lang="fr-FR"/>
           </a:p>
@@ -2400,7 +2400,7 @@
           <a:p>
             <a:fld id="{21B36A12-6976-4B31-BD04-D4227ACD3F51}" type="datetimeFigureOut">
               <a:rPr lang="fr-FR" smtClean="0"/>
-              <a:t>24/03/2026</a:t>
+              <a:t>06/05/2026</a:t>
             </a:fld>
             <a:endParaRPr lang="fr-FR"/>
           </a:p>
@@ -2688,7 +2688,7 @@
           <a:p>
             <a:fld id="{21B36A12-6976-4B31-BD04-D4227ACD3F51}" type="datetimeFigureOut">
               <a:rPr lang="fr-FR" smtClean="0"/>
-              <a:t>24/03/2026</a:t>
+              <a:t>06/05/2026</a:t>
             </a:fld>
             <a:endParaRPr lang="fr-FR"/>
           </a:p>
@@ -2929,7 +2929,7 @@
           <a:p>
             <a:fld id="{21B36A12-6976-4B31-BD04-D4227ACD3F51}" type="datetimeFigureOut">
               <a:rPr lang="fr-FR" smtClean="0"/>
-              <a:t>24/03/2026</a:t>
+              <a:t>06/05/2026</a:t>
             </a:fld>
             <a:endParaRPr lang="fr-FR"/>
           </a:p>
@@ -10223,7 +10223,7 @@
         <p:spPr>
           <a:xfrm>
             <a:off x="138480" y="90791"/>
-            <a:ext cx="3059620" cy="369332"/>
+            <a:ext cx="3322897" cy="369332"/>
           </a:xfrm>
           <a:prstGeom prst="rect">
             <a:avLst/>
@@ -10237,8 +10237,12 @@
           <a:lstStyle/>
           <a:p>
             <a:r>
+              <a:rPr lang="fr-FR"/>
+              <a:t>Données saproxyliques </a:t>
+            </a:r>
+            <a:r>
               <a:rPr lang="fr-FR" dirty="0"/>
-              <a:t>Données carabiques – </a:t>
+              <a:t>– </a:t>
             </a:r>
             <a:r>
               <a:rPr lang="fr-FR" dirty="0" err="1"/>

</xml_diff>